<commit_message>
模型盘点页明确作者单位：Google Research/Amazon Science/Salesforce/Harvard+MIT林肯实验室/CMU/NTU+阿里/港科大+阿里/Nokia Bell Labs/微软研究院/Meta
Co-authored-by: Cursor <cursoragent@cursor.com>
</commit_message>
<xml_diff>
--- a/AI物理感知平台-华为汇报.pptx
+++ b/AI物理感知平台-华为汇报.pptx
@@ -10868,7 +10868,7 @@
                 <a:ea typeface="Microsoft YaHei"/>
                 <a:cs typeface="Microsoft YaHei"/>
               </a:rPr>
-              <a:t>模型 / 出处</a:t>
+              <a:t>模型 / 作者单位</a:t>
             </a:r>
           </a:p>
         </p:txBody>
@@ -11084,8 +11084,8 @@
         </p:nvSpPr>
         <p:spPr>
           <a:xfrm>
-            <a:off x="566928" y="1719072"/>
-            <a:ext cx="2103120" cy="658368"/>
+            <a:off x="566928" y="1700784"/>
+            <a:ext cx="2103120" cy="694944"/>
           </a:xfrm>
           <a:prstGeom prst="rect">
             <a:avLst/>
@@ -11102,7 +11102,7 @@
               </a:spcAft>
             </a:pPr>
             <a:r>
-              <a:rPr sz="1200" b="1">
+              <a:rPr sz="1100" b="1">
                 <a:solidFill>
                   <a:srgbClr val="C7000B"/>
                 </a:solidFill>
@@ -11120,7 +11120,7 @@
               </a:spcAft>
             </a:pPr>
             <a:r>
-              <a:rPr sz="1200" b="1">
+              <a:rPr sz="1100" b="1">
                 <a:solidFill>
                   <a:srgbClr val="C7000B"/>
                 </a:solidFill>
@@ -11128,7 +11128,25 @@
                 <a:ea typeface="Microsoft YaHei"/>
                 <a:cs typeface="Microsoft YaHei"/>
               </a:rPr>
-              <a:t>Google 2026</a:t>
+              <a:t>Google Research</a:t>
+            </a:r>
+          </a:p>
+          <a:p>
+            <a:pPr algn="l">
+              <a:spcAft>
+                <a:spcPts val="200"/>
+              </a:spcAft>
+            </a:pPr>
+            <a:r>
+              <a:rPr sz="1100" b="1">
+                <a:solidFill>
+                  <a:srgbClr val="C7000B"/>
+                </a:solidFill>
+                <a:latin typeface="Microsoft YaHei"/>
+                <a:ea typeface="Microsoft YaHei"/>
+                <a:cs typeface="Microsoft YaHei"/>
+              </a:rPr>
+              <a:t>ICML'24 / 3.0 2026</a:t>
             </a:r>
           </a:p>
         </p:txBody>
@@ -11398,8 +11416,8 @@
         </p:nvSpPr>
         <p:spPr>
           <a:xfrm>
-            <a:off x="566928" y="2542032"/>
-            <a:ext cx="2103120" cy="658368"/>
+            <a:off x="566928" y="2523744"/>
+            <a:ext cx="2103120" cy="694944"/>
           </a:xfrm>
           <a:prstGeom prst="rect">
             <a:avLst/>
@@ -11416,7 +11434,7 @@
               </a:spcAft>
             </a:pPr>
             <a:r>
-              <a:rPr sz="1200" b="1">
+              <a:rPr sz="1100" b="1">
                 <a:solidFill>
                   <a:srgbClr val="C7000B"/>
                 </a:solidFill>
@@ -11434,7 +11452,7 @@
               </a:spcAft>
             </a:pPr>
             <a:r>
-              <a:rPr sz="1200" b="1">
+              <a:rPr sz="1100" b="1">
                 <a:solidFill>
                   <a:srgbClr val="C7000B"/>
                 </a:solidFill>
@@ -11442,7 +11460,25 @@
                 <a:ea typeface="Microsoft YaHei"/>
                 <a:cs typeface="Microsoft YaHei"/>
               </a:rPr>
-              <a:t>Amazon 2024</a:t>
+              <a:t>Amazon Science</a:t>
+            </a:r>
+          </a:p>
+          <a:p>
+            <a:pPr algn="l">
+              <a:spcAft>
+                <a:spcPts val="200"/>
+              </a:spcAft>
+            </a:pPr>
+            <a:r>
+              <a:rPr sz="1100" b="1">
+                <a:solidFill>
+                  <a:srgbClr val="C7000B"/>
+                </a:solidFill>
+                <a:latin typeface="Microsoft YaHei"/>
+                <a:ea typeface="Microsoft YaHei"/>
+                <a:cs typeface="Microsoft YaHei"/>
+              </a:rPr>
+              <a:t>ICML'24</a:t>
             </a:r>
           </a:p>
         </p:txBody>
@@ -11676,8 +11712,8 @@
         </p:nvSpPr>
         <p:spPr>
           <a:xfrm>
-            <a:off x="566928" y="3364992"/>
-            <a:ext cx="2103120" cy="658368"/>
+            <a:off x="566928" y="3346704"/>
+            <a:ext cx="2103120" cy="694944"/>
           </a:xfrm>
           <a:prstGeom prst="rect">
             <a:avLst/>
@@ -11694,7 +11730,7 @@
               </a:spcAft>
             </a:pPr>
             <a:r>
-              <a:rPr sz="1200" b="1">
+              <a:rPr sz="1100" b="1">
                 <a:solidFill>
                   <a:srgbClr val="C7000B"/>
                 </a:solidFill>
@@ -11712,7 +11748,7 @@
               </a:spcAft>
             </a:pPr>
             <a:r>
-              <a:rPr sz="1200" b="1">
+              <a:rPr sz="1100" b="1">
                 <a:solidFill>
                   <a:srgbClr val="C7000B"/>
                 </a:solidFill>
@@ -11720,7 +11756,25 @@
                 <a:ea typeface="Microsoft YaHei"/>
                 <a:cs typeface="Microsoft YaHei"/>
               </a:rPr>
-              <a:t>Salesforce 2024</a:t>
+              <a:t>Salesforce AI Research</a:t>
+            </a:r>
+          </a:p>
+          <a:p>
+            <a:pPr algn="l">
+              <a:spcAft>
+                <a:spcPts val="200"/>
+              </a:spcAft>
+            </a:pPr>
+            <a:r>
+              <a:rPr sz="1100" b="1">
+                <a:solidFill>
+                  <a:srgbClr val="C7000B"/>
+                </a:solidFill>
+                <a:latin typeface="Microsoft YaHei"/>
+                <a:ea typeface="Microsoft YaHei"/>
+                <a:cs typeface="Microsoft YaHei"/>
+              </a:rPr>
+              <a:t>ICML'24</a:t>
             </a:r>
           </a:p>
         </p:txBody>
@@ -11972,8 +12026,8 @@
         </p:nvSpPr>
         <p:spPr>
           <a:xfrm>
-            <a:off x="566928" y="4187952"/>
-            <a:ext cx="2103120" cy="658368"/>
+            <a:off x="566928" y="4169664"/>
+            <a:ext cx="2103120" cy="694944"/>
           </a:xfrm>
           <a:prstGeom prst="rect">
             <a:avLst/>
@@ -11990,7 +12044,7 @@
               </a:spcAft>
             </a:pPr>
             <a:r>
-              <a:rPr sz="1200" b="1">
+              <a:rPr sz="1100" b="1">
                 <a:solidFill>
                   <a:srgbClr val="C7000B"/>
                 </a:solidFill>
@@ -12008,7 +12062,7 @@
               </a:spcAft>
             </a:pPr>
             <a:r>
-              <a:rPr sz="1200" b="1">
+              <a:rPr sz="1100" b="1">
                 <a:solidFill>
                   <a:srgbClr val="C7000B"/>
                 </a:solidFill>
@@ -12016,7 +12070,25 @@
                 <a:ea typeface="Microsoft YaHei"/>
                 <a:cs typeface="Microsoft YaHei"/>
               </a:rPr>
-              <a:t>Harvard NeurIPS'24</a:t>
+              <a:t>Harvard + MIT Lincoln Lab</a:t>
+            </a:r>
+          </a:p>
+          <a:p>
+            <a:pPr algn="l">
+              <a:spcAft>
+                <a:spcPts val="200"/>
+              </a:spcAft>
+            </a:pPr>
+            <a:r>
+              <a:rPr sz="1100" b="1">
+                <a:solidFill>
+                  <a:srgbClr val="C7000B"/>
+                </a:solidFill>
+                <a:latin typeface="Microsoft YaHei"/>
+                <a:ea typeface="Microsoft YaHei"/>
+                <a:cs typeface="Microsoft YaHei"/>
+              </a:rPr>
+              <a:t>NeurIPS'24</a:t>
             </a:r>
           </a:p>
         </p:txBody>
@@ -12268,8 +12340,8 @@
         </p:nvSpPr>
         <p:spPr>
           <a:xfrm>
-            <a:off x="566928" y="5010912"/>
-            <a:ext cx="2103120" cy="658368"/>
+            <a:off x="566928" y="4992624"/>
+            <a:ext cx="2103120" cy="694944"/>
           </a:xfrm>
           <a:prstGeom prst="rect">
             <a:avLst/>
@@ -12286,7 +12358,7 @@
               </a:spcAft>
             </a:pPr>
             <a:r>
-              <a:rPr sz="1200" b="1">
+              <a:rPr sz="1100" b="1">
                 <a:solidFill>
                   <a:srgbClr val="C7000B"/>
                 </a:solidFill>
@@ -12304,7 +12376,7 @@
               </a:spcAft>
             </a:pPr>
             <a:r>
-              <a:rPr sz="1200" b="1">
+              <a:rPr sz="1100" b="1">
                 <a:solidFill>
                   <a:srgbClr val="C7000B"/>
                 </a:solidFill>
@@ -12312,7 +12384,25 @@
                 <a:ea typeface="Microsoft YaHei"/>
                 <a:cs typeface="Microsoft YaHei"/>
               </a:rPr>
-              <a:t>CMU ICML'24</a:t>
+              <a:t>CMU Auton Lab</a:t>
+            </a:r>
+          </a:p>
+          <a:p>
+            <a:pPr algn="l">
+              <a:spcAft>
+                <a:spcPts val="200"/>
+              </a:spcAft>
+            </a:pPr>
+            <a:r>
+              <a:rPr sz="1100" b="1">
+                <a:solidFill>
+                  <a:srgbClr val="C7000B"/>
+                </a:solidFill>
+                <a:latin typeface="Microsoft YaHei"/>
+                <a:ea typeface="Microsoft YaHei"/>
+                <a:cs typeface="Microsoft YaHei"/>
+              </a:rPr>
+              <a:t>ICML'24</a:t>
             </a:r>
           </a:p>
         </p:txBody>
@@ -13014,7 +13104,7 @@
                 <a:ea typeface="Microsoft YaHei"/>
                 <a:cs typeface="Microsoft YaHei"/>
               </a:rPr>
-              <a:t>模型 / 出处</a:t>
+              <a:t>模型 / 作者单位</a:t>
             </a:r>
           </a:p>
         </p:txBody>
@@ -13191,8 +13281,8 @@
         </p:nvSpPr>
         <p:spPr>
           <a:xfrm>
-            <a:off x="566928" y="1682496"/>
-            <a:ext cx="2194560" cy="548640"/>
+            <a:off x="566928" y="1673352"/>
+            <a:ext cx="2194560" cy="585216"/>
           </a:xfrm>
           <a:prstGeom prst="rect">
             <a:avLst/>
@@ -13209,7 +13299,7 @@
               </a:spcAft>
             </a:pPr>
             <a:r>
-              <a:rPr sz="1200" b="1">
+              <a:rPr sz="1000" b="1">
                 <a:solidFill>
                   <a:srgbClr val="C7000B"/>
                 </a:solidFill>
@@ -13227,7 +13317,25 @@
               </a:spcAft>
             </a:pPr>
             <a:r>
-              <a:rPr sz="1200" b="1">
+              <a:rPr sz="1000" b="1">
+                <a:solidFill>
+                  <a:srgbClr val="C7000B"/>
+                </a:solidFill>
+                <a:latin typeface="Microsoft YaHei"/>
+                <a:ea typeface="Microsoft YaHei"/>
+                <a:cs typeface="Microsoft YaHei"/>
+              </a:rPr>
+              <a:t>南洋理工+阿里巴巴</a:t>
+            </a:r>
+          </a:p>
+          <a:p>
+            <a:pPr algn="l">
+              <a:spcAft>
+                <a:spcPts val="200"/>
+              </a:spcAft>
+            </a:pPr>
+            <a:r>
+              <a:rPr sz="1000" b="1">
                 <a:solidFill>
                   <a:srgbClr val="C7000B"/>
                 </a:solidFill>
@@ -13430,8 +13538,8 @@
         </p:nvSpPr>
         <p:spPr>
           <a:xfrm>
-            <a:off x="566928" y="2368296"/>
-            <a:ext cx="2194560" cy="548640"/>
+            <a:off x="566928" y="2359152"/>
+            <a:ext cx="2194560" cy="585216"/>
           </a:xfrm>
           <a:prstGeom prst="rect">
             <a:avLst/>
@@ -13448,7 +13556,7 @@
               </a:spcAft>
             </a:pPr>
             <a:r>
-              <a:rPr sz="1200" b="1">
+              <a:rPr sz="1000" b="1">
                 <a:solidFill>
                   <a:srgbClr val="C7000B"/>
                 </a:solidFill>
@@ -13466,7 +13574,25 @@
               </a:spcAft>
             </a:pPr>
             <a:r>
-              <a:rPr sz="1200" b="1">
+              <a:rPr sz="1000" b="1">
+                <a:solidFill>
+                  <a:srgbClr val="C7000B"/>
+                </a:solidFill>
+                <a:latin typeface="Microsoft YaHei"/>
+                <a:ea typeface="Microsoft YaHei"/>
+                <a:cs typeface="Microsoft YaHei"/>
+              </a:rPr>
+              <a:t>港科大+阿里巴巴</a:t>
+            </a:r>
+          </a:p>
+          <a:p>
+            <a:pPr algn="l">
+              <a:spcAft>
+                <a:spcPts val="200"/>
+              </a:spcAft>
+            </a:pPr>
+            <a:r>
+              <a:rPr sz="1000" b="1">
                 <a:solidFill>
                   <a:srgbClr val="C7000B"/>
                 </a:solidFill>
@@ -13570,7 +13696,7 @@
                 <a:ea typeface="Microsoft YaHei"/>
                 <a:cs typeface="Microsoft YaHei"/>
               </a:rPr>
-              <a:t>真实设备大规模泛化；端侧 HAR SOTA</a:t>
+              <a:t>真实设备大规模泛化；端侧 HAR SOTA；外卖配送全国部署</a:t>
             </a:r>
           </a:p>
         </p:txBody>
@@ -13669,8 +13795,8 @@
         </p:nvSpPr>
         <p:spPr>
           <a:xfrm>
-            <a:off x="566928" y="3054096"/>
-            <a:ext cx="2194560" cy="548640"/>
+            <a:off x="566928" y="3044952"/>
+            <a:ext cx="2194560" cy="585216"/>
           </a:xfrm>
           <a:prstGeom prst="rect">
             <a:avLst/>
@@ -13687,7 +13813,7 @@
               </a:spcAft>
             </a:pPr>
             <a:r>
-              <a:rPr sz="1200" b="1">
+              <a:rPr sz="1000" b="1">
                 <a:solidFill>
                   <a:srgbClr val="C7000B"/>
                 </a:solidFill>
@@ -13705,7 +13831,25 @@
               </a:spcAft>
             </a:pPr>
             <a:r>
-              <a:rPr sz="1200" b="1">
+              <a:rPr sz="1000" b="1">
+                <a:solidFill>
+                  <a:srgbClr val="C7000B"/>
+                </a:solidFill>
+                <a:latin typeface="Microsoft YaHei"/>
+                <a:ea typeface="Microsoft YaHei"/>
+                <a:cs typeface="Microsoft YaHei"/>
+              </a:rPr>
+              <a:t>CMU AirLab</a:t>
+            </a:r>
+          </a:p>
+          <a:p>
+            <a:pPr algn="l">
+              <a:spcAft>
+                <a:spcPts val="200"/>
+              </a:spcAft>
+            </a:pPr>
+            <a:r>
+              <a:rPr sz="1000" b="1">
                 <a:solidFill>
                   <a:srgbClr val="C7000B"/>
                 </a:solidFill>
@@ -13908,8 +14052,8 @@
         </p:nvSpPr>
         <p:spPr>
           <a:xfrm>
-            <a:off x="566928" y="3739896"/>
-            <a:ext cx="2194560" cy="548640"/>
+            <a:off x="566928" y="3730752"/>
+            <a:ext cx="2194560" cy="585216"/>
           </a:xfrm>
           <a:prstGeom prst="rect">
             <a:avLst/>
@@ -13926,7 +14070,7 @@
               </a:spcAft>
             </a:pPr>
             <a:r>
-              <a:rPr sz="1200" b="1">
+              <a:rPr sz="1000" b="1">
                 <a:solidFill>
                   <a:srgbClr val="C7000B"/>
                 </a:solidFill>
@@ -13944,7 +14088,7 @@
               </a:spcAft>
             </a:pPr>
             <a:r>
-              <a:rPr sz="1200" b="1">
+              <a:rPr sz="1000" b="1">
                 <a:solidFill>
                   <a:srgbClr val="C7000B"/>
                 </a:solidFill>
@@ -13952,7 +14096,25 @@
                 <a:ea typeface="Microsoft YaHei"/>
                 <a:cs typeface="Microsoft YaHei"/>
               </a:rPr>
-              <a:t>ICASSP'25</a:t>
+              <a:t>Nokia Bell Labs</a:t>
+            </a:r>
+          </a:p>
+          <a:p>
+            <a:pPr algn="l">
+              <a:spcAft>
+                <a:spcPts val="200"/>
+              </a:spcAft>
+            </a:pPr>
+            <a:r>
+              <a:rPr sz="1000" b="1">
+                <a:solidFill>
+                  <a:srgbClr val="C7000B"/>
+                </a:solidFill>
+                <a:latin typeface="Microsoft YaHei"/>
+                <a:ea typeface="Microsoft YaHei"/>
+                <a:cs typeface="Microsoft YaHei"/>
+              </a:rPr>
+              <a:t>+华盛顿大学 ICASSP'25</a:t>
             </a:r>
           </a:p>
         </p:txBody>
@@ -14147,8 +14309,8 @@
         </p:nvSpPr>
         <p:spPr>
           <a:xfrm>
-            <a:off x="566928" y="4425696"/>
-            <a:ext cx="2194560" cy="548640"/>
+            <a:off x="566928" y="4416552"/>
+            <a:ext cx="2194560" cy="585216"/>
           </a:xfrm>
           <a:prstGeom prst="rect">
             <a:avLst/>
@@ -14165,7 +14327,7 @@
               </a:spcAft>
             </a:pPr>
             <a:r>
-              <a:rPr sz="1200" b="1">
+              <a:rPr sz="1000" b="1">
                 <a:solidFill>
                   <a:srgbClr val="C7000B"/>
                 </a:solidFill>
@@ -14183,7 +14345,7 @@
               </a:spcAft>
             </a:pPr>
             <a:r>
-              <a:rPr sz="1200" b="1">
+              <a:rPr sz="1000" b="1">
                 <a:solidFill>
                   <a:srgbClr val="C7000B"/>
                 </a:solidFill>
@@ -14191,7 +14353,25 @@
                 <a:ea typeface="Microsoft YaHei"/>
                 <a:cs typeface="Microsoft YaHei"/>
               </a:rPr>
-              <a:t>SenSys'25</a:t>
+              <a:t>微软研究院+威斯康星</a:t>
+            </a:r>
+          </a:p>
+          <a:p>
+            <a:pPr algn="l">
+              <a:spcAft>
+                <a:spcPts val="200"/>
+              </a:spcAft>
+            </a:pPr>
+            <a:r>
+              <a:rPr sz="1000" b="1">
+                <a:solidFill>
+                  <a:srgbClr val="C7000B"/>
+                </a:solidFill>
+                <a:latin typeface="Microsoft YaHei"/>
+                <a:ea typeface="Microsoft YaHei"/>
+                <a:cs typeface="Microsoft YaHei"/>
+              </a:rPr>
+              <a:t>麦迪逊+港科大 SenSys'25</a:t>
             </a:r>
           </a:p>
         </p:txBody>
@@ -14386,8 +14566,8 @@
         </p:nvSpPr>
         <p:spPr>
           <a:xfrm>
-            <a:off x="566928" y="5111496"/>
-            <a:ext cx="2194560" cy="548640"/>
+            <a:off x="566928" y="5102352"/>
+            <a:ext cx="2194560" cy="585216"/>
           </a:xfrm>
           <a:prstGeom prst="rect">
             <a:avLst/>
@@ -14404,7 +14584,7 @@
               </a:spcAft>
             </a:pPr>
             <a:r>
-              <a:rPr sz="1200" b="1">
+              <a:rPr sz="1000" b="1">
                 <a:solidFill>
                   <a:srgbClr val="C7000B"/>
                 </a:solidFill>
@@ -14422,7 +14602,25 @@
               </a:spcAft>
             </a:pPr>
             <a:r>
-              <a:rPr sz="1200" b="1">
+              <a:rPr sz="1000" b="1">
+                <a:solidFill>
+                  <a:srgbClr val="C7000B"/>
+                </a:solidFill>
+                <a:latin typeface="Microsoft YaHei"/>
+                <a:ea typeface="Microsoft YaHei"/>
+                <a:cs typeface="Microsoft YaHei"/>
+              </a:rPr>
+              <a:t>Meta</a:t>
+            </a:r>
+          </a:p>
+          <a:p>
+            <a:pPr algn="l">
+              <a:spcAft>
+                <a:spcPts val="200"/>
+              </a:spcAft>
+            </a:pPr>
+            <a:r>
+              <a:rPr sz="1000" b="1">
                 <a:solidFill>
                   <a:srgbClr val="C7000B"/>
                 </a:solidFill>

</xml_diff>